<commit_message>
Lay the bundled template out for 16:9 and drop python-pptx's metadata
</commit_message>
<xml_diff>
--- a/crates/rpptx/assets/default.pptx
+++ b/crates/rpptx/assets/default.pptx
@@ -205,8 +205,8 @@
         </p:nvSpPr>
         <p:spPr>
           <a:xfrm>
-            <a:off x="1143000" y="685800"/>
-            <a:ext cx="4572000" cy="3429000"/>
+            <a:off x="685800" y="1143000"/>
+            <a:ext cx="5486400" cy="3086100"/>
           </a:xfrm>
           <a:prstGeom prst="rect">
             <a:avLst/>
@@ -238,8 +238,8 @@
         </p:nvSpPr>
         <p:spPr>
           <a:xfrm>
-            <a:off x="685800" y="4343400"/>
-            <a:ext cx="5486400" cy="4114800"/>
+            <a:off x="685800" y="4400550"/>
+            <a:ext cx="5486400" cy="3600450"/>
           </a:xfrm>
           <a:prstGeom prst="rect">
             <a:avLst/>
@@ -484,8 +484,8 @@
         </p:nvSpPr>
         <p:spPr>
           <a:xfrm>
-            <a:off x="685800" y="2130425"/>
-            <a:ext cx="7772400" cy="1470025"/>
+            <a:off x="1524000" y="1122363"/>
+            <a:ext cx="9144000" cy="2387600"/>
           </a:xfrm>
         </p:spPr>
         <p:txBody>
@@ -512,8 +512,8 @@
         </p:nvSpPr>
         <p:spPr>
           <a:xfrm>
-            <a:off x="1371600" y="3886200"/>
-            <a:ext cx="6400800" cy="1752600"/>
+            <a:off x="1524000" y="3602038"/>
+            <a:ext cx="9144000" cy="1655762"/>
           </a:xfrm>
         </p:spPr>
         <p:txBody>
@@ -896,8 +896,8 @@
         </p:nvSpPr>
         <p:spPr>
           <a:xfrm>
-            <a:off x="6629400" y="274638"/>
-            <a:ext cx="2057400" cy="5851525"/>
+            <a:off x="8724900" y="365125"/>
+            <a:ext cx="2628900" cy="5811838"/>
           </a:xfrm>
         </p:spPr>
         <p:txBody>
@@ -924,8 +924,8 @@
         </p:nvSpPr>
         <p:spPr>
           <a:xfrm>
-            <a:off x="457200" y="274638"/>
-            <a:ext cx="6019800" cy="5851525"/>
+            <a:off x="838200" y="365125"/>
+            <a:ext cx="7734300" cy="5811838"/>
           </a:xfrm>
         </p:spPr>
         <p:txBody>
@@ -1246,8 +1246,8 @@
         </p:nvSpPr>
         <p:spPr>
           <a:xfrm>
-            <a:off x="722313" y="4406900"/>
-            <a:ext cx="7772400" cy="1362075"/>
+            <a:off x="831850" y="1709738"/>
+            <a:ext cx="10515600" cy="2852737"/>
           </a:xfrm>
         </p:spPr>
         <p:txBody>
@@ -1278,8 +1278,8 @@
         </p:nvSpPr>
         <p:spPr>
           <a:xfrm>
-            <a:off x="722313" y="2906713"/>
-            <a:ext cx="7772400" cy="1500187"/>
+            <a:off x="831850" y="4589463"/>
+            <a:ext cx="10515600" cy="1500187"/>
           </a:xfrm>
         </p:spPr>
         <p:txBody>
@@ -1515,8 +1515,8 @@
         </p:nvSpPr>
         <p:spPr>
           <a:xfrm>
-            <a:off x="457200" y="1600200"/>
-            <a:ext cx="4038600" cy="4525963"/>
+            <a:off x="838200" y="1825625"/>
+            <a:ext cx="5181600" cy="4351338"/>
           </a:xfrm>
         </p:spPr>
         <p:txBody>
@@ -1600,8 +1600,8 @@
         </p:nvSpPr>
         <p:spPr>
           <a:xfrm>
-            <a:off x="4648200" y="1600200"/>
-            <a:ext cx="4038600" cy="4525963"/>
+            <a:off x="6172200" y="1825625"/>
+            <a:ext cx="5181600" cy="4351338"/>
           </a:xfrm>
         </p:spPr>
         <p:txBody>
@@ -1778,7 +1778,12 @@
             <p:ph type="title"/>
           </p:nvPr>
         </p:nvSpPr>
-        <p:spPr/>
+        <p:spPr>
+          <a:xfrm>
+            <a:off x="839788" y="365125"/>
+            <a:ext cx="10515600" cy="1325563"/>
+          </a:xfrm>
+        </p:spPr>
         <p:txBody>
           <a:bodyPr/>
           <a:lstStyle>
@@ -1807,8 +1812,8 @@
         </p:nvSpPr>
         <p:spPr>
           <a:xfrm>
-            <a:off x="457200" y="1535113"/>
-            <a:ext cx="4040188" cy="639762"/>
+            <a:off x="839788" y="1681163"/>
+            <a:ext cx="5157787" cy="823912"/>
           </a:xfrm>
         </p:spPr>
         <p:txBody>
@@ -1872,8 +1877,8 @@
         </p:nvSpPr>
         <p:spPr>
           <a:xfrm>
-            <a:off x="457200" y="2174875"/>
-            <a:ext cx="4040188" cy="3951288"/>
+            <a:off x="839788" y="2505075"/>
+            <a:ext cx="5157787" cy="3684588"/>
           </a:xfrm>
         </p:spPr>
         <p:txBody>
@@ -1957,8 +1962,8 @@
         </p:nvSpPr>
         <p:spPr>
           <a:xfrm>
-            <a:off x="4645025" y="1535113"/>
-            <a:ext cx="4041775" cy="639762"/>
+            <a:off x="6172200" y="1681163"/>
+            <a:ext cx="5183188" cy="823912"/>
           </a:xfrm>
         </p:spPr>
         <p:txBody>
@@ -2022,8 +2027,8 @@
         </p:nvSpPr>
         <p:spPr>
           <a:xfrm>
-            <a:off x="4645025" y="2174875"/>
-            <a:ext cx="4041775" cy="3951288"/>
+            <a:off x="6172200" y="2505075"/>
+            <a:ext cx="5183188" cy="3684588"/>
           </a:xfrm>
         </p:spPr>
         <p:txBody>
@@ -2415,8 +2420,8 @@
         </p:nvSpPr>
         <p:spPr>
           <a:xfrm>
-            <a:off x="457200" y="273050"/>
-            <a:ext cx="3008313" cy="1162050"/>
+            <a:off x="839788" y="457200"/>
+            <a:ext cx="3932237" cy="1600200"/>
           </a:xfrm>
         </p:spPr>
         <p:txBody>
@@ -2447,8 +2452,8 @@
         </p:nvSpPr>
         <p:spPr>
           <a:xfrm>
-            <a:off x="3575050" y="273050"/>
-            <a:ext cx="5111750" cy="5853113"/>
+            <a:off x="5183188" y="987425"/>
+            <a:ext cx="6172200" cy="4873625"/>
           </a:xfrm>
         </p:spPr>
         <p:txBody>
@@ -2532,8 +2537,8 @@
         </p:nvSpPr>
         <p:spPr>
           <a:xfrm>
-            <a:off x="457200" y="1435100"/>
-            <a:ext cx="3008313" cy="4691063"/>
+            <a:off x="839788" y="2057400"/>
+            <a:ext cx="3932237" cy="3811588"/>
           </a:xfrm>
         </p:spPr>
         <p:txBody>
@@ -2692,8 +2697,8 @@
         </p:nvSpPr>
         <p:spPr>
           <a:xfrm>
-            <a:off x="1792288" y="4800600"/>
-            <a:ext cx="5486400" cy="566738"/>
+            <a:off x="839788" y="457200"/>
+            <a:ext cx="3932237" cy="1600200"/>
           </a:xfrm>
         </p:spPr>
         <p:txBody>
@@ -2724,8 +2729,8 @@
         </p:nvSpPr>
         <p:spPr>
           <a:xfrm>
-            <a:off x="1792288" y="612775"/>
-            <a:ext cx="5486400" cy="4114800"/>
+            <a:off x="5183188" y="987425"/>
+            <a:ext cx="6172200" cy="4873625"/>
           </a:xfrm>
         </p:spPr>
         <p:txBody>
@@ -2785,8 +2790,8 @@
         </p:nvSpPr>
         <p:spPr>
           <a:xfrm>
-            <a:off x="1792288" y="5367338"/>
-            <a:ext cx="5486400" cy="804862"/>
+            <a:off x="839788" y="2057400"/>
+            <a:ext cx="3932237" cy="3811588"/>
           </a:xfrm>
         </p:spPr>
         <p:txBody>
@@ -2950,8 +2955,8 @@
         </p:nvSpPr>
         <p:spPr>
           <a:xfrm>
-            <a:off x="457200" y="274638"/>
-            <a:ext cx="8229600" cy="1143000"/>
+            <a:off x="838200" y="365125"/>
+            <a:ext cx="10515600" cy="1325563"/>
           </a:xfrm>
           <a:prstGeom prst="rect">
             <a:avLst/>
@@ -2983,8 +2988,8 @@
         </p:nvSpPr>
         <p:spPr>
           <a:xfrm>
-            <a:off x="457200" y="1600200"/>
-            <a:ext cx="8229600" cy="4525963"/>
+            <a:off x="838200" y="1825625"/>
+            <a:ext cx="10515600" cy="4351338"/>
           </a:xfrm>
           <a:prstGeom prst="rect">
             <a:avLst/>
@@ -3045,8 +3050,8 @@
         </p:nvSpPr>
         <p:spPr>
           <a:xfrm>
-            <a:off x="457200" y="6356350"/>
-            <a:ext cx="2133600" cy="365125"/>
+            <a:off x="838200" y="6356350"/>
+            <a:ext cx="2743200" cy="365125"/>
           </a:xfrm>
           <a:prstGeom prst="rect">
             <a:avLst/>
@@ -3086,8 +3091,8 @@
         </p:nvSpPr>
         <p:spPr>
           <a:xfrm>
-            <a:off x="3124200" y="6356350"/>
-            <a:ext cx="2895600" cy="365125"/>
+            <a:off x="4038600" y="6356350"/>
+            <a:ext cx="4114800" cy="365125"/>
           </a:xfrm>
           <a:prstGeom prst="rect">
             <a:avLst/>
@@ -3123,8 +3128,8 @@
         </p:nvSpPr>
         <p:spPr>
           <a:xfrm>
-            <a:off x="6553200" y="6356350"/>
-            <a:ext cx="2133600" cy="365125"/>
+            <a:off x="8610600" y="6356350"/>
+            <a:ext cx="2743200" cy="365125"/>
           </a:xfrm>
           <a:prstGeom prst="rect">
             <a:avLst/>

</xml_diff>

<commit_message>
F-X205, integrate PowerPoint parity and export repairs
Integrate the validated worker and preserve completed Word authoring contracts. Native widescreen geometry changes eight template members and fresh metadata changes one. Channel-directed PowerPoint interpolation is intentional. The current chart package expectation is source-attributed, with unchanged exact zero-pixel equality. All49 accepted deterministic hashes remain unchanged. Original failed attempts remain recorded, and full sprint verification is still due.

Tests, scoped worker gates and10 integrated qualified rows, clean integration review20
Harness, unchanged,49 accepted deterministic outputs
</commit_message>
<xml_diff>
--- a/crates/rpptx/assets/default.pptx
+++ b/crates/rpptx/assets/default.pptx
@@ -484,8 +484,8 @@
         </p:nvSpPr>
         <p:spPr>
           <a:xfrm>
-            <a:off x="685800" y="2130425"/>
-            <a:ext cx="7772400" cy="1470025"/>
+            <a:off x="1524000" y="1122363"/>
+            <a:ext cx="9144000" cy="2387600"/>
           </a:xfrm>
         </p:spPr>
         <p:txBody>
@@ -512,8 +512,8 @@
         </p:nvSpPr>
         <p:spPr>
           <a:xfrm>
-            <a:off x="1371600" y="3886200"/>
-            <a:ext cx="6400800" cy="1752600"/>
+            <a:off x="1524000" y="3602038"/>
+            <a:ext cx="9144000" cy="1655762"/>
           </a:xfrm>
         </p:spPr>
         <p:txBody>
@@ -896,8 +896,8 @@
         </p:nvSpPr>
         <p:spPr>
           <a:xfrm>
-            <a:off x="6629400" y="274638"/>
-            <a:ext cx="2057400" cy="5851525"/>
+            <a:off x="8724900" y="365125"/>
+            <a:ext cx="2628900" cy="5811838"/>
           </a:xfrm>
         </p:spPr>
         <p:txBody>
@@ -924,8 +924,8 @@
         </p:nvSpPr>
         <p:spPr>
           <a:xfrm>
-            <a:off x="457200" y="274638"/>
-            <a:ext cx="6019800" cy="5851525"/>
+            <a:off x="838200" y="365125"/>
+            <a:ext cx="7734300" cy="5811838"/>
           </a:xfrm>
         </p:spPr>
         <p:txBody>
@@ -1246,8 +1246,8 @@
         </p:nvSpPr>
         <p:spPr>
           <a:xfrm>
-            <a:off x="722313" y="4406900"/>
-            <a:ext cx="7772400" cy="1362075"/>
+            <a:off x="831850" y="1709738"/>
+            <a:ext cx="10515600" cy="2852737"/>
           </a:xfrm>
         </p:spPr>
         <p:txBody>
@@ -1278,8 +1278,8 @@
         </p:nvSpPr>
         <p:spPr>
           <a:xfrm>
-            <a:off x="722313" y="2906713"/>
-            <a:ext cx="7772400" cy="1500187"/>
+            <a:off x="831850" y="4589463"/>
+            <a:ext cx="10515600" cy="1500187"/>
           </a:xfrm>
         </p:spPr>
         <p:txBody>
@@ -1515,8 +1515,8 @@
         </p:nvSpPr>
         <p:spPr>
           <a:xfrm>
-            <a:off x="457200" y="1600200"/>
-            <a:ext cx="4038600" cy="4525963"/>
+            <a:off x="838200" y="1825625"/>
+            <a:ext cx="5181600" cy="4351338"/>
           </a:xfrm>
         </p:spPr>
         <p:txBody>
@@ -1600,8 +1600,8 @@
         </p:nvSpPr>
         <p:spPr>
           <a:xfrm>
-            <a:off x="4648200" y="1600200"/>
-            <a:ext cx="4038600" cy="4525963"/>
+            <a:off x="6172200" y="1825625"/>
+            <a:ext cx="5181600" cy="4351338"/>
           </a:xfrm>
         </p:spPr>
         <p:txBody>
@@ -1778,7 +1778,12 @@
             <p:ph type="title"/>
           </p:nvPr>
         </p:nvSpPr>
-        <p:spPr/>
+        <p:spPr>
+          <a:xfrm>
+            <a:off x="839788" y="365125"/>
+            <a:ext cx="10515600" cy="1325563"/>
+          </a:xfrm>
+        </p:spPr>
         <p:txBody>
           <a:bodyPr/>
           <a:lstStyle>
@@ -1807,8 +1812,8 @@
         </p:nvSpPr>
         <p:spPr>
           <a:xfrm>
-            <a:off x="457200" y="1535113"/>
-            <a:ext cx="4040188" cy="639762"/>
+            <a:off x="839788" y="1681163"/>
+            <a:ext cx="5157787" cy="823912"/>
           </a:xfrm>
         </p:spPr>
         <p:txBody>
@@ -1872,8 +1877,8 @@
         </p:nvSpPr>
         <p:spPr>
           <a:xfrm>
-            <a:off x="457200" y="2174875"/>
-            <a:ext cx="4040188" cy="3951288"/>
+            <a:off x="839788" y="2505075"/>
+            <a:ext cx="5157787" cy="3684588"/>
           </a:xfrm>
         </p:spPr>
         <p:txBody>
@@ -1957,8 +1962,8 @@
         </p:nvSpPr>
         <p:spPr>
           <a:xfrm>
-            <a:off x="4645025" y="1535113"/>
-            <a:ext cx="4041775" cy="639762"/>
+            <a:off x="6172200" y="1681163"/>
+            <a:ext cx="5183188" cy="823912"/>
           </a:xfrm>
         </p:spPr>
         <p:txBody>
@@ -2022,8 +2027,8 @@
         </p:nvSpPr>
         <p:spPr>
           <a:xfrm>
-            <a:off x="4645025" y="2174875"/>
-            <a:ext cx="4041775" cy="3951288"/>
+            <a:off x="6172200" y="2505075"/>
+            <a:ext cx="5183188" cy="3684588"/>
           </a:xfrm>
         </p:spPr>
         <p:txBody>
@@ -2415,8 +2420,8 @@
         </p:nvSpPr>
         <p:spPr>
           <a:xfrm>
-            <a:off x="457200" y="273050"/>
-            <a:ext cx="3008313" cy="1162050"/>
+            <a:off x="839788" y="457200"/>
+            <a:ext cx="3932237" cy="1600200"/>
           </a:xfrm>
         </p:spPr>
         <p:txBody>
@@ -2447,8 +2452,8 @@
         </p:nvSpPr>
         <p:spPr>
           <a:xfrm>
-            <a:off x="3575050" y="273050"/>
-            <a:ext cx="5111750" cy="5853113"/>
+            <a:off x="5183188" y="987425"/>
+            <a:ext cx="6172200" cy="4873625"/>
           </a:xfrm>
         </p:spPr>
         <p:txBody>
@@ -2532,8 +2537,8 @@
         </p:nvSpPr>
         <p:spPr>
           <a:xfrm>
-            <a:off x="457200" y="1435100"/>
-            <a:ext cx="3008313" cy="4691063"/>
+            <a:off x="839788" y="2057400"/>
+            <a:ext cx="3932237" cy="3811588"/>
           </a:xfrm>
         </p:spPr>
         <p:txBody>
@@ -2692,8 +2697,8 @@
         </p:nvSpPr>
         <p:spPr>
           <a:xfrm>
-            <a:off x="1792288" y="4800600"/>
-            <a:ext cx="5486400" cy="566738"/>
+            <a:off x="839788" y="457200"/>
+            <a:ext cx="3932237" cy="1600200"/>
           </a:xfrm>
         </p:spPr>
         <p:txBody>
@@ -2724,8 +2729,8 @@
         </p:nvSpPr>
         <p:spPr>
           <a:xfrm>
-            <a:off x="1792288" y="612775"/>
-            <a:ext cx="5486400" cy="4114800"/>
+            <a:off x="5183188" y="987425"/>
+            <a:ext cx="6172200" cy="4873625"/>
           </a:xfrm>
         </p:spPr>
         <p:txBody>
@@ -2785,8 +2790,8 @@
         </p:nvSpPr>
         <p:spPr>
           <a:xfrm>
-            <a:off x="1792288" y="5367338"/>
-            <a:ext cx="5486400" cy="804862"/>
+            <a:off x="839788" y="2057400"/>
+            <a:ext cx="3932237" cy="3811588"/>
           </a:xfrm>
         </p:spPr>
         <p:txBody>
@@ -2950,8 +2955,8 @@
         </p:nvSpPr>
         <p:spPr>
           <a:xfrm>
-            <a:off x="457200" y="274638"/>
-            <a:ext cx="8229600" cy="1143000"/>
+            <a:off x="838200" y="365125"/>
+            <a:ext cx="10515600" cy="1325563"/>
           </a:xfrm>
           <a:prstGeom prst="rect">
             <a:avLst/>
@@ -2983,8 +2988,8 @@
         </p:nvSpPr>
         <p:spPr>
           <a:xfrm>
-            <a:off x="457200" y="1600200"/>
-            <a:ext cx="8229600" cy="4525963"/>
+            <a:off x="838200" y="1825625"/>
+            <a:ext cx="10515600" cy="4351338"/>
           </a:xfrm>
           <a:prstGeom prst="rect">
             <a:avLst/>
@@ -3045,8 +3050,8 @@
         </p:nvSpPr>
         <p:spPr>
           <a:xfrm>
-            <a:off x="457200" y="6356350"/>
-            <a:ext cx="2133600" cy="365125"/>
+            <a:off x="838200" y="6356350"/>
+            <a:ext cx="2743200" cy="365125"/>
           </a:xfrm>
           <a:prstGeom prst="rect">
             <a:avLst/>
@@ -3086,8 +3091,8 @@
         </p:nvSpPr>
         <p:spPr>
           <a:xfrm>
-            <a:off x="3124200" y="6356350"/>
-            <a:ext cx="2895600" cy="365125"/>
+            <a:off x="4038600" y="6356350"/>
+            <a:ext cx="4114800" cy="365125"/>
           </a:xfrm>
           <a:prstGeom prst="rect">
             <a:avLst/>
@@ -3123,8 +3128,8 @@
         </p:nvSpPr>
         <p:spPr>
           <a:xfrm>
-            <a:off x="6553200" y="6356350"/>
-            <a:ext cx="2133600" cy="365125"/>
+            <a:off x="8610600" y="6356350"/>
+            <a:ext cx="2743200" cy="365125"/>
           </a:xfrm>
           <a:prstGeom prst="rect">
             <a:avLst/>

</xml_diff>